<commit_message>
added word doc also for project brief
</commit_message>
<xml_diff>
--- a/Tower Defence Game/Docs/project brief.pptx
+++ b/Tower Defence Game/Docs/project brief.pptx
@@ -105,6 +105,11 @@
       </a:defRPr>
     </a:lvl9pPr>
   </p:defaultTextStyle>
+  <p:extLst>
+    <p:ext uri="{EFAFB233-063F-42B5-8137-9DF3F51BA10A}">
+      <p15:sldGuideLst xmlns:p15="http://schemas.microsoft.com/office/powerpoint/2012/main"/>
+    </p:ext>
+  </p:extLst>
 </p:presentation>
 </file>
 
@@ -121,12 +126,12 @@
   <pc:docChgLst>
     <pc:chgData name="Dean Jones (12MG)" userId="255a7527-22e4-4dd2-9172-fe890232cf1e" providerId="ADAL" clId="{A9C70086-A7DF-4ECC-B35B-8F6849A3BDD8}"/>
     <pc:docChg chg="undo custSel addSld modSld">
-      <pc:chgData name="Dean Jones (12MG)" userId="255a7527-22e4-4dd2-9172-fe890232cf1e" providerId="ADAL" clId="{A9C70086-A7DF-4ECC-B35B-8F6849A3BDD8}" dt="2026-04-27T08:44:26.397" v="1462" actId="20577"/>
+      <pc:chgData name="Dean Jones (12MG)" userId="255a7527-22e4-4dd2-9172-fe890232cf1e" providerId="ADAL" clId="{A9C70086-A7DF-4ECC-B35B-8F6849A3BDD8}" dt="2026-04-27T09:28:45.887" v="1463" actId="20577"/>
       <pc:docMkLst>
         <pc:docMk/>
       </pc:docMkLst>
       <pc:sldChg chg="addSp delSp modSp new mod">
-        <pc:chgData name="Dean Jones (12MG)" userId="255a7527-22e4-4dd2-9172-fe890232cf1e" providerId="ADAL" clId="{A9C70086-A7DF-4ECC-B35B-8F6849A3BDD8}" dt="2026-04-27T08:44:26.397" v="1462" actId="20577"/>
+        <pc:chgData name="Dean Jones (12MG)" userId="255a7527-22e4-4dd2-9172-fe890232cf1e" providerId="ADAL" clId="{A9C70086-A7DF-4ECC-B35B-8F6849A3BDD8}" dt="2026-04-27T09:28:45.887" v="1463" actId="20577"/>
         <pc:sldMkLst>
           <pc:docMk/>
           <pc:sldMk cId="3148520095" sldId="256"/>
@@ -540,7 +545,7 @@
           </ac:spMkLst>
         </pc:spChg>
         <pc:spChg chg="add mod">
-          <ac:chgData name="Dean Jones (12MG)" userId="255a7527-22e4-4dd2-9172-fe890232cf1e" providerId="ADAL" clId="{A9C70086-A7DF-4ECC-B35B-8F6849A3BDD8}" dt="2026-04-27T08:44:26.397" v="1462" actId="20577"/>
+          <ac:chgData name="Dean Jones (12MG)" userId="255a7527-22e4-4dd2-9172-fe890232cf1e" providerId="ADAL" clId="{A9C70086-A7DF-4ECC-B35B-8F6849A3BDD8}" dt="2026-04-27T09:28:45.887" v="1463" actId="20577"/>
           <ac:spMkLst>
             <pc:docMk/>
             <pc:sldMk cId="3148520095" sldId="256"/>
@@ -5619,7 +5624,7 @@
         <p:spPr>
           <a:xfrm>
             <a:off x="130628" y="8621486"/>
-            <a:ext cx="1268937" cy="830997"/>
+            <a:ext cx="1268937" cy="1015663"/>
           </a:xfrm>
           <a:prstGeom prst="rect">
             <a:avLst/>
@@ -5650,8 +5655,15 @@
           <a:p>
             <a:r>
               <a:rPr lang="en-GB" sz="1200" dirty="0"/>
-              <a:t>Similar Projects:</a:t>
-            </a:r>
+              <a:t>Similar </a:t>
+            </a:r>
+            <a:r>
+              <a:rPr lang="en-GB" sz="1200"/>
+              <a:t>Projects:</a:t>
+            </a:r>
+          </a:p>
+          <a:p>
+            <a:endParaRPr lang="en-GB" sz="1200" dirty="0"/>
           </a:p>
         </p:txBody>
       </p:sp>

</xml_diff>